<commit_message>
Rename code decks to -Lab; rewrite all slide notes in an academic register
- Code decks are now NN-...-Lab.pptx in both languages (suffix in
  tools/lib/lab.js); notes files renamed to <deck>-Lab.md; READMEs updated
- All 1,834 slide notes (en + it) rewritten: each note states the slide's
  role in the lecture's argument, defines terms precisely, and links
  backwards and forwards to the lectures that prepare or complete it
- Generated lab-deck note templates (lib/lab.js NOTE) revised likewise
- Checked against the previous notes: no numbers, code names or facts
  lost; every added "Lecture NN" reference verified
- Decks and notes rebuilt; all checks pass

Co-Authored-By: Claude Opus 5.5 <noreply@anthropic.com>
</commit_message>
<xml_diff>
--- a/en/slides/00-Computer_Architecture-Course_Introduction.pptx
+++ b/en/slides/00-Computer_Architecture-Course_Introduction.pptx
@@ -126,21 +126,21 @@
   <p:extLst>
     <p:ext uri="{521415D9-36F7-43E2-AB2F-B90AF26B5E84}">
       <p14:sectionLst xmlns:p14="http://schemas.microsoft.com/office/powerpoint/2010/main">
-        <p14:section name="Opening" id="{43535eb5-53d6-14c7-a0b3-3f2caa278d58}">
+        <p14:section name="Opening" id="{c9c0534d-cacd-95f0-9c56-219319b4c8eb}">
           <p14:sldIdLst>
             <p14:sldId id="256"/>
             <p14:sldId id="257"/>
             <p14:sldId id="258"/>
           </p14:sldIdLst>
         </p14:section>
-        <p14:section name="A new approach" id="{49b863d9-f5ba-ace9-0f3d-1b2f4b8f697f}">
+        <p14:section name="A new approach" id="{37791fa2-8a0d-8fbd-2c38-72b5faec0aad}">
           <p14:sldIdLst>
             <p14:sldId id="259"/>
             <p14:sldId id="260"/>
             <p14:sldId id="261"/>
           </p14:sldIdLst>
         </p14:section>
-        <p14:section name="PRG32 and RISC-V" id="{13fc409e-9dd5-0c3e-d8ed-a66f1adedba7}">
+        <p14:section name="PRG32 and RISC-V" id="{f17a52c4-2239-d7f1-d397-6179b114fccf}">
           <p14:sldIdLst>
             <p14:sldId id="262"/>
             <p14:sldId id="263"/>
@@ -148,14 +148,14 @@
             <p14:sldId id="265"/>
           </p14:sldIdLst>
         </p14:section>
-        <p14:section name="The course project: Verm1" id="{6424533f-097c-9a2b-fc5b-b5ff8cd12008}">
+        <p14:section name="The course project: Verm1" id="{3b9365b7-8dec-86a5-e5f0-a47850c9d1b5}">
           <p14:sldIdLst>
             <p14:sldId id="266"/>
             <p14:sldId id="267"/>
             <p14:sldId id="268"/>
           </p14:sldIdLst>
         </p14:section>
-        <p14:section name="Organisation and assessment" id="{78602208-cc2e-ad6b-f183-d2b88e88f0aa}">
+        <p14:section name="Organisation and assessment" id="{8962c083-8133-5218-86ce-b04142ed9ab9}">
           <p14:sldIdLst>
             <p14:sldId id="269"/>
             <p14:sldId id="270"/>
@@ -164,7 +164,7 @@
             <p14:sldId id="273"/>
           </p14:sldIdLst>
         </p14:section>
-        <p14:section name="Material and first contact" id="{e7efa7d1-96d5-3a03-c7a6-ef49d31a9bde}">
+        <p14:section name="Material and first contact" id="{84ed8a85-d035-d79d-5ff9-e4e61e207c7b}">
           <p14:sldIdLst>
             <p14:sldId id="274"/>
             <p14:sldId id="275"/>
@@ -574,7 +574,7 @@
           <a:p>
             <a:r>
               <a:rPr lang="en-US" dirty="0"/>
-              <a:t>This is the opening lecture of the course. It does not teach a topic: it explains how the course works, which machine you will program, which game you will build and how you will be assessed. The quotation from The Matrix is a promise: a computer is a system, and a system that you can open and read stops being a mystery. Keep the title in mind, program first, formalise later: it is the method of every lecture that follows, and the reason why you will type assembly before you meet the theory that explains it.
+              <a:t>This opening lecture introduces no technical topic. Its purpose is to set out the terms of the course: the method by which it proceeds, the machine on which its ideas are tested, the project that runs through it, and the rules by which learning is assessed. The epigraph from The Matrix states the underlying conviction: a computer is a system, and a system whose parts can be opened, named and reasoned about ceases to be opaque. The subtitle, program first, formalise later, is the methodological thesis of the whole course, and the remaining slides should be read as its consequences.
 Learning status: UNDERSTAND NOW, by the end of this lecture you explain it, trace it and apply it on your own; USE NOW, you follow and use the recipe today; how it works inside is explained later, or is not part of the course; UNDERSTAND LATER, recognise the name and what it is for; a later lecture explains it. A slide without a badge is context: a story, an example, a question, an exercise.
 Learning status of this lecture. UNDERSTAND NOW: the program-first method; the rules of the course. USE NOW: the complete program, the PRG32 tools (used, not studied, in this course). UNDERSTAND LATER: the pieces of PRG32 (Lecture 01); RISC and an open ISA (Lecture 03); the Verm1 project (Lecture 07). A slide without a badge is context: a story, an example, a question, an exercise.
 For the lecturer: Opening lecture. The administrative facts (timetable, assessment) are carried over from the Italian 2026/27 deck; from this year there is one midterm test, with ten questions and two exercises. Dates still marked TBD must be filled in before class.</a:t>
@@ -665,7 +665,7 @@
           <a:p>
             <a:r>
               <a:rPr lang="en-US" dirty="0"/>
-              <a:t>This table is the course on one page. The left column lists the formal topics; the right column says where you meet each one first, on the machine. Two's complement appears as a position that walks left past zero; Boolean algebra as the test of a button; sequential networks as a counter that survives from one frame to the next. Come back to this slide at the start of each block: it tells you which experience the coming theory is going to explain, and it is a good checklist when you revise.
+              <a:t>This table is the course on a single page. The left column lists the formal topics; the right column identifies where each is first encountered experimentally, on the machine. Two's complement appears as a position that moves left past zero; Boolean algebra as the test of a button; sequential networks as a counter that persists from one frame to the next. Every topic is thus met twice, first as a phenomenon and then as a theory. The table is worth revisiting at the start of each block, because it states which experience the forthcoming theory will explain, and it serves as a checklist for revision.
 For the lecturer: This table is the course in one slide. Come back to it at the start of each block.</a:t>
             </a:r>
             <a:endParaRPr lang="en-US" dirty="0"/>
@@ -754,7 +754,7 @@
           <a:p>
             <a:r>
               <a:rPr lang="en-US" dirty="0"/>
-              <a:t>The game is Verm1, read "vermone", the big worm: a tribute to Snake. A worm moves on a grid, eats, grows and must not bite itself. The rules fit in one sentence, yet the program needs almost everything the course teaches: numbers for positions, logic for the buttons, memory for the body, calls and division for the score. You write every line yourself; there is no game engine behind it, only the few calls of PRG32 that draw a rectangle, read the buttons or play a note. At the end the game carries your name.
+              <a:t>The course project is Verm1, pronounced "vermone", the big worm: a tribute to Snake, in which a worm moves on a grid, eats, grows, and must not collide with itself. The rules fit in one sentence, yet the implementation draws on nearly every topic of the course: numerical representation for positions, Boolean logic for the controls, memory organisation for the body, procedure calls and division for the score. Every line is written by the student; there is no game engine, only the handful of PRG32 calls that draw a rectangle, read the buttons or play a note. The finished game bears its author's name.
 UNDERSTAND LATER: the Verm1 project (studied in Lecture 07).
 For the lecturer: The project is the thread of the course: each part uses exactly what the four lectures before it have taught. The reference implementation of Verm1 was contributed by Giuseppe Coviello; its sources are in the verm1 folder of the course material and are built and played automatically by the tests.</a:t>
             </a:r>
@@ -844,7 +844,7 @@
           <a:p>
             <a:r>
               <a:rPr lang="en-US" dirty="0"/>
-              <a:t>The project has four parts and a publication, and each part comes after the block of lectures that it uses. Part 1 (Lecture 07) uses numbers: a grid and a head that moves. Part 2 (Lecture 12) uses logic: steering, food and a score. Part 3 (Lecture 17) uses state and memory: a body, collisions and three screens. Part 4 (Lecture 22) uses the machine: digits, levels and fast drawing. Lecture 23 packages the game for the Store. The caption states the rule that matters most to you: every part ends with a game that runs.
+              <a:t>The project unfolds in four parts and a publication, each part following the block of lectures whose content it applies. Part 1 (Lecture 07) applies numerical representation: a grid and a head that moves. Part 2 (Lecture 12) applies logic: steering, food and a score. Part 3 (Lecture 17) applies state and memory: a body, collisions and three screens. Part 4 (Lecture 22) applies the organisation of the machine: decimal digits, levels and efficient drawing. Lecture 23 packages the game for the Cartridge Store. The caption states the invariant that matters most: every part ends with a game that runs.
 UNDERSTAND LATER: the Verm1 project (studied in Lecture 07).
 For the lecturer: Every fifth deck is a tutorial. The numbers are those of the lectures: 07, 12, 17 and 22 for the four parts, 23 for the publication.</a:t>
             </a:r>
@@ -934,7 +934,7 @@
           <a:p>
             <a:r>
               <a:rPr lang="en-US" dirty="0"/>
-              <a:t>The calendar of the course, in blocks. After three opening lectures there are four blocks of four lectures: Information (what a bit means), Logic (how bits are combined), State and memory (how bits are remembered) and The machine (the processor and its devices). After each block comes a part of Verm1. Lecture 23 publishes the game and Lecture 24 looks at larger machines. The lecture numbers on this slide are the ones used everywhere in the material: when a slide says "Lecture 13", this is the table that tells you where it sits.
+              <a:t>The calendar of the course, organised in blocks. After the three opening lectures come four blocks of four lectures: Information (what a bit means), Logic (how bits are combined), State and memory (how bits are retained) and The machine (the processor and its devices). Each block is followed by a part of Verm1; Lecture 23 publishes the game and Lecture 24 looks beyond the single core. The lecture numbers on this slide are those used throughout the material, so that a reference such as "Lecture 13" can always be located here.
 For the lecturer: The order was chosen for learning: first what a bit means, then how bits are combined, then how they are remembered, then the machine that does all three; the processor comes before the devices it drives. After each block the project uses it. The last lecture is an outlook, before the visit to the Department's computing systems.</a:t>
             </a:r>
             <a:endParaRPr lang="en-US" dirty="0"/>
@@ -1023,7 +1023,7 @@
           <a:p>
             <a:r>
               <a:rPr lang="en-US" dirty="0"/>
-              <a:t>Four meetings a week from September to December, all in Aula 1: Monday afternoon and Wednesday morning with Prof. Montella, Tuesday and Friday morning with Prof. Staffa. Lectures and laboratory do not always alternate strictly: an internal calendar, shared with the class, gives the actual distribution week by week. Check that calendar, not only this table, before deciding which material to prepare for a given day.
+              <a:t>The course meets four times a week from September to December, always in Aula 1: Monday afternoon and Wednesday morning with Prof. Montella, Tuesday and Friday morning with Prof. Staffa. Lectures and laboratory sessions do not alternate rigidly; an internal calendar, shared with the class, gives the actual distribution week by week. That calendar, rather than this table alone, should be consulted when deciding what to prepare for a given day.
 UNDERSTAND NOW: the rules of the course.
 For the lecturer: We will share an internal calendar with the actual distribution of lectures and laboratory sessions.</a:t>
             </a:r>
@@ -1113,7 +1113,7 @@
           <a:p>
             <a:r>
               <a:rPr lang="en-US" dirty="0"/>
-              <a:t>There is one midterm test: ten multiple-choice questions and two exercises, on paper, in about 45 minutes. Bring an identity document and a pen, and know your institutional e-mail address and student number. The test measures two things at once: how you are doing, and how the course is doing. The best preparation is already built into the lectures: each one ends with questions of exactly this kind. Answering them week by week costs a few minutes; leaving them all for the night before does not work.
+              <a:t>There is a single midterm test, consisting of ten multiple-choice questions and two exercises, taken on paper in about 45 minutes. Students must bring an identity document and a pen, and know their institutional e-mail address and student number. The test serves two purposes at once: it measures each student's progress and it measures the progress of the course. Preparation is built into the lectures, each of which closes with questions of exactly this type. Answering them week by week costs a few minutes; deferring them all to the night before is ineffective.
 UNDERSTAND NOW: the rules of the course.
 For the lecturer: One midterm from 2026/27 (there were two). The date is TBD: fill it in. The weight of the test is decided after evaluating the correct behaviour of the students in the room. Booking rules are not on the slide: say them in class if they apply.</a:t>
             </a:r>
@@ -1203,7 +1203,7 @@
           <a:p>
             <a:r>
               <a:rPr lang="en-US" dirty="0"/>
-              <a:t>The rule for the midterm and the exam is short: no devices and no help, human or artificial, of any kind. This includes ChatGPT, other language models and every form of generative AI. Copying cancels your test immediately. The rule is not hostility towards technology, which you will use every day in this course: it follows from what the test is for. A test measures what you know; an answer produced by something else measures nothing and helps nobody, least of all you.
+              <a:t>The rule for the midterm and the final examination is brief: no devices and no assistance of any kind, human or artificial, including ChatGPT, other large language models and all forms of generative AI. Copying annuls the test immediately. The rule does not express hostility towards technology, which the course uses daily; it follows from the purpose of an assessment. An examination measures what the candidate knows; an answer produced by another agent measures nothing and benefits nobody, least of all the candidate.
 UNDERSTAND NOW: the rules of the course.
 For the lecturer: If more than two tests have to be cancelled for inadequate behaviour, the whole midterm is cancelled for everyone.</a:t>
             </a:r>
@@ -1293,7 +1293,7 @@
           <a:p>
             <a:r>
               <a:rPr lang="en-US" dirty="0"/>
-              <a:t>The exam has two parts and you must pass both: theory, an oral with questions on the whole syllabus, some of which need a diagram or a calculation at the board; and practice, the laboratory exam with Prof. Staffa. Each counts for half, and the final mark is the mean of the two. Note that the oral can also lower the mark obtained in the midterm: the midterm is a real result, not a guarantee. How the midterm enters the theory mark is explained in class.
+              <a:t>The examination has two components, both of which must be passed: a theory component, an oral examination on the whole syllabus in which some answers require a diagram or a calculation at the board; and a practical component, the laboratory examination with Prof. Staffa. Each contributes one half, and the final mark is their mean. The oral examination may also lower the mark obtained in the midterm: the midterm is a genuine result, not a guarantee. The way in which the midterm enters the theory mark is explained in class.
 UNDERSTAND NOW: the rules of the course.
 For the lecturer: Midterm and exam results are kept within the current academic year. The official syllabus describes the written part as exercises on the analysis and synthesis of logic networks and on RISC-V assembly development on PRG32. How the midterm enters the theory mark is said in class: the slide does not give a formula.</a:t>
             </a:r>
@@ -1383,7 +1383,7 @@
           <a:p>
             <a:r>
               <a:rPr lang="en-US" dirty="0"/>
-              <a:t>To record the final mark you need a positive result in both parts, and the recording happens only during a theory session; the laboratory exam is usually a week earlier. Book both on Esse3. The two frequent questions have the same answer: yes, you may take the theory before the practice, and your result is kept for the academic year, but nothing is recorded until both parts are passed. Plan the two exams together rather than one at a time.
+              <a:t>The final mark is recorded only when both components have been passed, and recording takes place exclusively during a theory session; the laboratory examination normally precedes it by about a week. Both must be booked on Esse3. The two most frequent questions share an answer: the theory component may be taken before the practical one, and its result is retained for the academic year, but nothing is recorded until both are passed. It is therefore advisable to plan the two examinations together.
 UNDERSTAND NOW: the rules of the course.
 For the lecturer: Dates of the sessions were empty in the source deck: add them when published.</a:t>
             </a:r>
@@ -1473,7 +1473,7 @@
           <a:p>
             <a:r>
               <a:rPr lang="en-US" dirty="0"/>
-              <a:t>The material has four sources. The slides are in a shared Google Drive folder and are published on the e-learning portal. PRG32 and its textbook, Playing with RISC-V, are free and open source on GitHub. The reference textbooks are Patterson and Hennessy, in the RISC-V edition, and Tanenbaum and Austin; both exist in Italian. The official RISC-V documentation is at riscv.org. You do not need to buy everything on the first day: start with the slides and the PRG32 material, and choose one textbook when the formal topics begin.
+              <a:t>The material comes from four sources. The slides are kept in a shared Google Drive folder and periodically published on the e-learning portal. PRG32 and its textbook, Playing with RISC-V, are free and open source on GitHub. The reference textbooks are Patterson and Hennessy, Computer Organization and Design, RISC-V edition, and Tanenbaum and Austin, Structured Computer Organization; both are available in Italian. The authoritative documentation of the architecture is published at riscv.org. Nothing need be purchased on the first day: the slides and the PRG32 material suffice until the formal topics begin, at which point one textbook should be chosen.
 For the lecturer: Drive folder: https://drive.google.com/drive/folders/15Kdu8XYbQQVP0ieuZA5OIEmoKqDjQ-eR?usp=sharing . E-learning: https://elearning.uniparthenope.it/course/view.php?id=107 . Italian editions: Tanenbaum, Austin, Architettura dei calcolatori. Un approccio strutturale (Pearson); Patterson, Hennessy, Struttura e progetto dei calcolatori: progettare con RISC-V (Zanichelli).</a:t>
             </a:r>
             <a:endParaRPr lang="en-US" dirty="0"/>
@@ -1562,7 +1562,7 @@
           <a:p>
             <a:r>
               <a:rPr lang="en-US" dirty="0"/>
-              <a:t>The lecture has five parts: the people and the hours, the approach, the machine, the project and the rules. They follow the questions a new student asks, in the order in which the answers make sense: you cannot judge the rules before you know what the course asks of you. If you are impatient to hear about the exam, it is the last part, and it is complete. Use this list as a map while you listen, and again when you come back to the slides to look something up.
+              <a:t>The lecture is organised in five parts: the people and the hours, the approach, the machine, the project, and the rules. The order is deliberate. A set of rules can be judged only once one knows what the course demands, and what it demands follows from its method; hence the method precedes the regulations. Students who wish to go straight to the examination will find it treated completely in the last part. The list may be used as a map during the lecture and, later, as an index when consulting the slides.
 For the lecturer: Five parts, about ten minutes each. The last part is the one students ask about: say at once that it comes at the end.</a:t>
             </a:r>
             <a:endParaRPr lang="en-US" dirty="0"/>
@@ -1651,7 +1651,7 @@
           <a:p>
             <a:r>
               <a:rPr lang="en-US" dirty="0"/>
-              <a:t>Six groups of questions to break the ice: hardware, software, culture, concepts, RISC-V and yourselves. There are no right answers, and nobody is assessed. The purpose is practical: the answers tell the lecturer how much can be taken for granted in the first weeks. If you have never built a computer or read a line of assembly, you are in the majority and in the right place; if you have, you will be able to help the person sitting next to you.
+              <a:t>Six groups of questions open the conversation: hardware, software, culture, concepts, RISC-V and the students themselves. There are no right answers and nothing is assessed. The purpose is diagnostic: the answers indicate how much may be taken for granted in the first weeks. Students who have never assembled a computer or read a line of assembly are in the majority and exactly where the course expects them to be; those who have will find occasions to help their neighbours, which is itself one of the most effective ways of learning.
 Learning status, recap. UNDERSTAND NOW: the program-first method; the rules of the course. USE NOW: the complete program, the PRG32 tools (used, not studied, in this course). UNDERSTAND LATER: the pieces of PRG32 (Lecture 01); RISC and an open ISA (Lecture 03); the Verm1 project (Lecture 07). A slide without a badge is context: a story, an example, a question, an exercise.
 For the lecturer: Ice-breaker. Keep it quick; note the answers: they tell you how fast Lecture 02 can go.</a:t>
             </a:r>
@@ -1741,7 +1741,7 @@
           <a:p>
             <a:r>
               <a:rPr lang="en-US" dirty="0"/>
-              <a:t>Six facts about the course. It is worth 12 credits and 96 hours, split evenly between lectures (Prof. Montella) and laboratory (Prof. Staffa): two lecturers, one course, one mark. There are no formal prerequisites, and this is meant literally: nobody assumes that you have programmed before. What you do need is curiosity about how a computer really works. Note the office hours and the Teams code now: questions asked early, in the first weeks, are the cheapest ones to answer.
+              <a:t>The course carries 12 ECTS credits, corresponding to 96 hours, divided equally between lectures (Prof. Montella) and laboratory (Prof. Staffa): two instructors, one course, one final mark. There are no formal prerequisites, and the statement is meant literally: no prior programming experience is assumed. What is required is a sustained curiosity about how a computer actually works. Office hours and the Teams code should be noted at once; questions raised in the first weeks are the least costly to resolve.
 For the lecturer: Teams link from the original deck: https://teams.microsoft.com/l/channel/19%3Af4f24e8de71f424395ba903febdc4766%40thread.tacv2/General?groupId=09ae05f6-46f6-4441-ab7b-7522f88007d5 . The team code c7rf33g comes from the official syllabus and may change: announce any change in class. Accenture SuperSkills: https://richiediaccesso.uniparthenope.it/reservations?type=J</a:t>
             </a:r>
             <a:endParaRPr lang="en-US" dirty="0"/>
@@ -1830,7 +1830,7 @@
           <a:p>
             <a:r>
               <a:rPr lang="en-US" dirty="0"/>
-              <a:t>One sentence, to remember. Program first means that from day one you write RISC-V instructions that a real processor executes. Formalise later means that definitions and theorems come as answers: each one explains something your own program has already shown you. The order matters because a question you have met yourself is easier to remember than an answer to a question you were never asked. Nothing is taken away from the theory: it is all there, and it is examined; it simply arrives second.
+              <a:t>The method in one sentence. Program first means that, from the first week, students write RISC-V instructions that a physical processor executes. Formalise later means that definitions and theorems enter as answers: each explains a phenomenon that the student's own program has already exhibited. The ordering rests on a well-established observation in learning: a question one has encountered personally gives the subsequent answer a place to attach to. Nothing is removed from the theory; it is presented in full and it is examined. It simply arrives second.
 UNDERSTAND NOW: the program-first method.</a:t>
             </a:r>
             <a:endParaRPr lang="en-US" dirty="0"/>
@@ -1919,7 +1919,7 @@
           <a:p>
             <a:r>
               <a:rPr lang="en-US" dirty="0"/>
-              <a:t>The same four steps are repeated for every topic. Play: type a few instructions and run them. Observe: something happens that you did not fully expect, for example a number that passes zero and becomes 0xFFFFFFFF. Formalise: the lecture gives the rule that explains it, in this case two's complement. Return: go back to the machine and predict the result before you run the program. The last step is the test of understanding: if your prediction is right, you know the rule; if it is wrong, the machine tells you at once, and without a mark.
+              <a:t>Every topic traverses the same four phases. Play: a few instructions are written and executed. Observe: the machine produces an effect that was not fully anticipated, for instance a counter that, decremented past zero, displays 0xFFFFFFFF. Formalise: the lecture supplies the rule that accounts for the effect, here two's complement representation. Return: one goes back to the machine and predicts the outcome before running the program. The fourth phase is the criterion of understanding. A correct prediction shows that the rule has been grasped; an incorrect one is refuted immediately by the machine, at no cost.
 UNDERSTAND NOW: the program-first method.</a:t>
             </a:r>
             <a:endParaRPr lang="en-US" dirty="0"/>
@@ -2008,7 +2008,7 @@
           <a:p>
             <a:r>
               <a:rPr lang="en-US" dirty="0"/>
-              <a:t>These are the aims of the course, in the words of the official syllabus. Read them as a chain: first the aspects of architecture, then the low-level languages to program a machine, then the formal tools from which a processor is built (Boolean algebra, binary arithmetic), then the structure of CPU, memory and input/output, and finally assembly code that makes all this visible. The picture is Pong on PRG32: a game of a few hundred instructions, each of which you will be able to read by the end.</a:t>
+              <a:t>These are the aims stated in the official syllabus, and they form a chain. First, the fundamental aspects of computer architecture; then the low-level languages, machine language and assembly, through which a machine is programmed; then the formal tools from which a processor is constructed, namely Boolean algebra and binary arithmetic; then the organisation of processor, memory and input/output; and finally assembly code, in which all these layers become visible at once. The illustration is Pong running on PRG32: a program of a few hundred instructions, every one of which the student will be able to read by the end of the course.</a:t>
             </a:r>
             <a:endParaRPr lang="en-US" dirty="0"/>
           </a:p>
@@ -2096,7 +2096,7 @@
           <a:p>
             <a:r>
               <a:rPr lang="en-US" dirty="0"/>
-              <a:t>PRG32 is a small game console that you program in assembly or C. Three ideas matter here. First, your code is real machine code for a 32-bit RISC-V processor, called RV32IMAC: it is executed, not imitated. Second, the contract with the machine is three functions that you write: init runs once, update and draw run once per frame, many times per second. Third, a finished program is a cartridge, one small file ending in .prg32. The screen has 320 by 200 pixels: small enough that you can reason about every one of them.
+              <a:t>PRG32 is a small game console programmed in assembly or in C. Three properties are essential. First, the student's code is genuine machine code for a 32-bit RISC-V processor implementing the RV32IMAC instruction set: it is executed, not interpreted or imitated. Second, the interface between a program and the machine is a contract of three functions written by the student: init, executed once, and update and draw, executed once per frame. Third, a finished program is a cartridge, a single small file with the extension .prg32. The display measures 320 by 200 pixels, small enough for every pixel to be the object of reasoning.
 UNDERSTAND LATER: the pieces of PRG32 (studied in Lecture 01).
 For the lecturer: PRG32: https://github.com/riscv-prg32/PRG32 . Textbook: https://github.com/riscv-prg32/Playing-with-RISC-V_PRG32_textbook</a:t>
             </a:r>
@@ -2186,7 +2186,7 @@
           <a:p>
             <a:r>
               <a:rPr lang="en-US" dirty="0"/>
-              <a:t>PRG32-QT is PRG32 as an application for your laptop: it runs the same cartridges without a board. In debug mode it shows the machine while the game runs: you can pause, execute one instruction at a time, stop at a breakpoint, read the 32 registers and any 128 bytes of memory, and slow the program down to one hundredth of its speed. In the picture the game is on the left and the machine on the right. Take the last line as a definition: you understand a program when you can say what each register will hold before you press Step.
+              <a:t>PRG32-QT is PRG32 as a desktop application: it executes the same cartridges without any hardware. In debug mode it exposes the state of the machine while the game runs: execution can be paused, advanced one instruction at a time, stopped at a breakpoint; the 32 registers and any window of 128 bytes of memory can be inspected; and the program can be slowed to one hundredth of its speed. The final line of the slide deserves to be taken as an operational definition: a program is understood when one can state the content of each register before pressing Step.
 UNDERSTAND LATER: the pieces of PRG32 (studied in Lecture 01).
 For the lecturer: Settings, Run cartridges in RISC-V debug mode. Lecture 01 installs it; the same cartridge also runs on the kit and on the QEMU emulator, and Lecture 01 compares the three. The debugger is used from Lecture 02 and systematically in the Verm1 tutorials: each one has a debugging section with a precise procedure.</a:t>
             </a:r>
@@ -2276,7 +2276,7 @@
           <a:p>
             <a:r>
               <a:rPr lang="en-US" dirty="0"/>
-              <a:t>Four reasons for RISC-V. It is open: the instruction set is a public standard, and anyone may build a processor that implements it. It is small: about forty base instructions and thirty-two registers, an amount that one semester can cover completely. It is real: these are the instructions of billions of chips on the market, not a teaching toy. And it is strategic for Europe, which builds its own processors on it. The second reason is the one you will feel most: you will know the whole base instruction set, not a selection.
+              <a:t>Four arguments motivate the choice of RISC-V. It is open: the instruction set architecture is a public standard that anyone may implement without licence fees. It is small: roughly forty base instructions and thirty-two general-purpose registers, a body of knowledge that a single semester can cover exhaustively. It is real: these instructions are executed by billions of commercial devices, so nothing learned here is a pedagogical artefact. And it is strategic: European initiatives build their own processors upon it. The second argument has the most direct consequence for the student, who will master the complete base instruction set rather than a selection of it.
 UNDERSTAND LATER: RISC and an open ISA (studied in Lecture 03).
 For the lecturer: DARE: Digital Autonomy with RISC-V in Europe, a EuroHPC Joint Undertaking project. See chapter 1 of the PRG32 textbook for the full argument and sources.</a:t>
             </a:r>
@@ -3356,7 +3356,7 @@
                 <a:ea typeface="Calibri" pitchFamily="34" charset="-122"/>
                 <a:cs typeface="Calibri" pitchFamily="34" charset="-120"/>
               </a:rPr>
-              <a:t>00-Computer_Architecture-Course_Introduction-Code.pptx</a:t>
+              <a:t>00-Computer_Architecture-Course_Introduction-Lab.pptx</a:t>
             </a:r>
             <a:endParaRPr lang="en-US" sz="1300" dirty="0"/>
           </a:p>

</xml_diff>